<commit_message>
first commit for ocr testing part
</commit_message>
<xml_diff>
--- a/project_documents/Mid_Term_PPT_Government_Document_RAG.pptx
+++ b/project_documents/Mid_Term_PPT_Government_Document_RAG.pptx
@@ -189,7 +189,7 @@
           <a:p>
             <a:fld id="{1D8BD707-D9CF-40AE-B4C6-C98DA3205C09}" type="datetimeFigureOut">
               <a:rPr lang="en-US"/>
-              <a:t>9/17/2026</a:t>
+              <a:t>9/18/2026</a:t>
             </a:fld>
             <a:endParaRPr lang="en-US"/>
           </a:p>
@@ -360,7 +360,7 @@
           <a:p>
             <a:fld id="{1D8BD707-D9CF-40AE-B4C6-C98DA3205C09}" type="datetimeFigureOut">
               <a:rPr lang="en-US"/>
-              <a:t>9/17/2026</a:t>
+              <a:t>9/18/2026</a:t>
             </a:fld>
             <a:endParaRPr lang="en-US"/>
           </a:p>
@@ -574,7 +574,7 @@
           <a:p>
             <a:fld id="{1D8BD707-D9CF-40AE-B4C6-C98DA3205C09}" type="datetimeFigureOut">
               <a:rPr lang="en-US"/>
-              <a:t>9/17/2026</a:t>
+              <a:t>9/18/2026</a:t>
             </a:fld>
             <a:endParaRPr lang="en-US"/>
           </a:p>
@@ -722,7 +722,7 @@
           <a:p>
             <a:fld id="{1D8BD707-D9CF-40AE-B4C6-C98DA3205C09}" type="datetimeFigureOut">
               <a:rPr lang="en-US"/>
-              <a:t>9/17/2026</a:t>
+              <a:t>9/18/2026</a:t>
             </a:fld>
             <a:endParaRPr lang="en-US"/>
           </a:p>
@@ -841,7 +841,7 @@
           <a:p>
             <a:fld id="{1D8BD707-D9CF-40AE-B4C6-C98DA3205C09}" type="datetimeFigureOut">
               <a:rPr lang="en-US"/>
-              <a:t>9/17/2026</a:t>
+              <a:t>9/18/2026</a:t>
             </a:fld>
             <a:endParaRPr lang="en-US"/>
           </a:p>
@@ -1082,7 +1082,7 @@
           <a:p>
             <a:fld id="{1D8BD707-D9CF-40AE-B4C6-C98DA3205C09}" type="datetimeFigureOut">
               <a:rPr lang="en-US"/>
-              <a:t>9/17/2026</a:t>
+              <a:t>9/18/2026</a:t>
             </a:fld>
             <a:endParaRPr lang="en-US"/>
           </a:p>

</xml_diff>